<commit_message>
Add patient-journey matrix query and cleanup edits for PowerPoint deck
</commit_message>
<xml_diff>
--- a/SOC/Site of Care - reproduction (Mac build).pptx
+++ b/SOC/Site of Care - reproduction (Mac build).pptx
@@ -5768,7 +5768,7 @@
                 <a:ea typeface="Arial" pitchFamily="34" charset="-122"/>
                 <a:cs typeface="Arial" pitchFamily="34" charset="-120"/>
               </a:rPr>
-              <a:t>0.6% of all patients</a:t>
+              <a:t>0.6% of treated patients</a:t>
             </a:r>
             <a:endParaRPr lang="en-US" sz="2200" dirty="0"/>
           </a:p>
@@ -5885,7 +5885,7 @@
                 <a:ea typeface="Arial" pitchFamily="34" charset="-122"/>
                 <a:cs typeface="Arial" pitchFamily="34" charset="-120"/>
               </a:rPr>
-              <a:t>53.5% of all patients</a:t>
+              <a:t>53.5% of treated patients</a:t>
             </a:r>
             <a:endParaRPr lang="en-US" sz="3000" dirty="0"/>
           </a:p>
@@ -6002,7 +6002,7 @@
                 <a:ea typeface="Arial" pitchFamily="34" charset="-122"/>
                 <a:cs typeface="Arial" pitchFamily="34" charset="-120"/>
               </a:rPr>
-              <a:t>45.6% of all patients</a:t>
+              <a:t>45.6% of treated patients</a:t>
             </a:r>
             <a:endParaRPr lang="en-US" sz="3000" dirty="0"/>
           </a:p>
@@ -6119,7 +6119,7 @@
                 <a:ea typeface="Arial" pitchFamily="34" charset="-122"/>
                 <a:cs typeface="Arial" pitchFamily="34" charset="-120"/>
               </a:rPr>
-              <a:t>0.3% of all patients</a:t>
+              <a:t>0.3% of treated patients</a:t>
             </a:r>
             <a:endParaRPr lang="en-US" sz="2200" dirty="0"/>
           </a:p>
@@ -6231,7 +6231,7 @@
         </p:nvSpPr>
         <p:spPr>
           <a:xfrm>
-            <a:off x="566928" y="5715000"/>
+            <a:off x="566928" y="5623560"/>
             <a:ext cx="10972800" cy="457200"/>
           </a:xfrm>
           <a:prstGeom prst="rect">
@@ -6259,7 +6259,7 @@
                 <a:ea typeface="Arial" pitchFamily="34" charset="-122"/>
                 <a:cs typeface="Arial" pitchFamily="34" charset="-120"/>
               </a:rPr>
-              <a:t>Source: McKesson (Compile) medical claims (2021 to 2025). Start = site of first treatment claim; End = site of last treatment claim. Patients may have activity across both settings.</a:t>
+              <a:t>The journey is measured on the treatment cohort (patients with at least one treatment claim), slightly larger than the 16,246 diagnosed patients shown on slide 3 because it does not require a prior diagnosis claim. Source: McKesson (Compile) medical claims (2021 to 2025). Start = first treatment claim; End = last treatment claim.</a:t>
             </a:r>
             <a:endParaRPr lang="en-US" sz="850" dirty="0"/>
           </a:p>
@@ -14139,7 +14139,7 @@
                 <a:ea typeface="Arial" pitchFamily="34" charset="-122"/>
                 <a:cs typeface="Arial" pitchFamily="34" charset="-120"/>
               </a:rPr>
-              <a:t>211</a:t>
+              <a:t>210</a:t>
             </a:r>
             <a:endParaRPr lang="en-US" sz="1100" dirty="0"/>
           </a:p>
@@ -14154,7 +14154,7 @@
         <p:spPr>
           <a:xfrm>
             <a:off x="731520" y="4526280"/>
-            <a:ext cx="872038" cy="64008"/>
+            <a:ext cx="867905" cy="64008"/>
           </a:xfrm>
           <a:prstGeom prst="rect">
             <a:avLst/>
@@ -14173,43 +14173,197 @@
         </p:nvSpPr>
         <p:spPr>
           <a:xfrm>
-            <a:off x="731520" y="4718304"/>
-            <a:ext cx="3191256" cy="640080"/>
-          </a:xfrm>
-          <a:prstGeom prst="rect">
-            <a:avLst/>
-          </a:prstGeom>
-          <a:noFill/>
-          <a:ln/>
-        </p:spPr>
-        <p:txBody>
-          <a:bodyPr wrap="square" lIns="0" tIns="0" rIns="0" bIns="0" rtlCol="0" anchor="t"/>
+            <a:off x="731520" y="4672584"/>
+            <a:ext cx="2286000" cy="274320"/>
+          </a:xfrm>
+          <a:prstGeom prst="rect">
+            <a:avLst/>
+          </a:prstGeom>
+          <a:noFill/>
+          <a:ln/>
+        </p:spPr>
+        <p:txBody>
+          <a:bodyPr wrap="square" lIns="0" tIns="0" rIns="0" bIns="0" rtlCol="0" anchor="ctr"/>
           <a:lstStyle/>
           <a:p>
             <a:pPr indent="0" marL="0">
-              <a:lnSpc>
-                <a:spcPct val="105000"/>
-              </a:lnSpc>
-              <a:buNone/>
-            </a:pPr>
-            <a:r>
-              <a:rPr lang="en-US" sz="950" i="1" dirty="0">
-                <a:solidFill>
-                  <a:srgbClr val="6B7280"/>
-                </a:solidFill>
-                <a:latin typeface="Arial" pitchFamily="34" charset="0"/>
-                <a:ea typeface="Arial" pitchFamily="34" charset="-122"/>
-                <a:cs typeface="Arial" pitchFamily="34" charset="-120"/>
-              </a:rPr>
-              <a:t>One account carries most of the state; the rest is a long tail of smaller sites.</a:t>
-            </a:r>
-            <a:endParaRPr lang="en-US" sz="950" dirty="0"/>
-          </a:p>
-        </p:txBody>
-      </p:sp>
-      <p:sp>
-        <p:nvSpPr>
-          <p:cNvPr id="49" name="Shape 47"/>
+              <a:buNone/>
+            </a:pPr>
+            <a:r>
+              <a:rPr lang="en-US" sz="1050" dirty="0">
+                <a:solidFill>
+                  <a:srgbClr val="222831"/>
+                </a:solidFill>
+                <a:latin typeface="Arial" pitchFamily="34" charset="0"/>
+                <a:ea typeface="Arial" pitchFamily="34" charset="-122"/>
+                <a:cs typeface="Arial" pitchFamily="34" charset="-120"/>
+              </a:rPr>
+              <a:t>Shannon Medical Center</a:t>
+            </a:r>
+            <a:endParaRPr lang="en-US" sz="1050" dirty="0"/>
+          </a:p>
+        </p:txBody>
+      </p:sp>
+      <p:sp>
+        <p:nvSpPr>
+          <p:cNvPr id="49" name="Text 47"/>
+          <p:cNvSpPr/>
+          <p:nvPr/>
+        </p:nvSpPr>
+        <p:spPr>
+          <a:xfrm>
+            <a:off x="3310128" y="4672584"/>
+            <a:ext cx="640080" cy="274320"/>
+          </a:xfrm>
+          <a:prstGeom prst="rect">
+            <a:avLst/>
+          </a:prstGeom>
+          <a:noFill/>
+          <a:ln/>
+        </p:spPr>
+        <p:txBody>
+          <a:bodyPr wrap="square" lIns="0" tIns="0" rIns="0" bIns="0" rtlCol="0" anchor="ctr"/>
+          <a:lstStyle/>
+          <a:p>
+            <a:pPr algn="r" indent="0" marL="0">
+              <a:buNone/>
+            </a:pPr>
+            <a:r>
+              <a:rPr lang="en-US" sz="1100" b="1" dirty="0">
+                <a:solidFill>
+                  <a:srgbClr val="16324B"/>
+                </a:solidFill>
+                <a:latin typeface="Arial" pitchFamily="34" charset="0"/>
+                <a:ea typeface="Arial" pitchFamily="34" charset="-122"/>
+                <a:cs typeface="Arial" pitchFamily="34" charset="-120"/>
+              </a:rPr>
+              <a:t>20</a:t>
+            </a:r>
+            <a:endParaRPr lang="en-US" sz="1100" dirty="0"/>
+          </a:p>
+        </p:txBody>
+      </p:sp>
+      <p:sp>
+        <p:nvSpPr>
+          <p:cNvPr id="50" name="Shape 48"/>
+          <p:cNvSpPr/>
+          <p:nvPr/>
+        </p:nvSpPr>
+        <p:spPr>
+          <a:xfrm>
+            <a:off x="731520" y="4965192"/>
+            <a:ext cx="109728" cy="64008"/>
+          </a:xfrm>
+          <a:prstGeom prst="rect">
+            <a:avLst/>
+          </a:prstGeom>
+          <a:solidFill>
+            <a:srgbClr val="6E7F32"/>
+          </a:solidFill>
+          <a:ln/>
+        </p:spPr>
+      </p:sp>
+      <p:sp>
+        <p:nvSpPr>
+          <p:cNvPr id="51" name="Text 49"/>
+          <p:cNvSpPr/>
+          <p:nvPr/>
+        </p:nvSpPr>
+        <p:spPr>
+          <a:xfrm>
+            <a:off x="731520" y="5111496"/>
+            <a:ext cx="2286000" cy="274320"/>
+          </a:xfrm>
+          <a:prstGeom prst="rect">
+            <a:avLst/>
+          </a:prstGeom>
+          <a:noFill/>
+          <a:ln/>
+        </p:spPr>
+        <p:txBody>
+          <a:bodyPr wrap="square" lIns="0" tIns="0" rIns="0" bIns="0" rtlCol="0" anchor="ctr"/>
+          <a:lstStyle/>
+          <a:p>
+            <a:pPr indent="0" marL="0">
+              <a:buNone/>
+            </a:pPr>
+            <a:r>
+              <a:rPr lang="en-US" sz="1050" dirty="0">
+                <a:solidFill>
+                  <a:srgbClr val="222831"/>
+                </a:solidFill>
+                <a:latin typeface="Arial" pitchFamily="34" charset="0"/>
+                <a:ea typeface="Arial" pitchFamily="34" charset="-122"/>
+                <a:cs typeface="Arial" pitchFamily="34" charset="-120"/>
+              </a:rPr>
+              <a:t>Providence St. Joseph Health</a:t>
+            </a:r>
+            <a:endParaRPr lang="en-US" sz="1050" dirty="0"/>
+          </a:p>
+        </p:txBody>
+      </p:sp>
+      <p:sp>
+        <p:nvSpPr>
+          <p:cNvPr id="52" name="Text 50"/>
+          <p:cNvSpPr/>
+          <p:nvPr/>
+        </p:nvSpPr>
+        <p:spPr>
+          <a:xfrm>
+            <a:off x="3310128" y="5111496"/>
+            <a:ext cx="640080" cy="274320"/>
+          </a:xfrm>
+          <a:prstGeom prst="rect">
+            <a:avLst/>
+          </a:prstGeom>
+          <a:noFill/>
+          <a:ln/>
+        </p:spPr>
+        <p:txBody>
+          <a:bodyPr wrap="square" lIns="0" tIns="0" rIns="0" bIns="0" rtlCol="0" anchor="ctr"/>
+          <a:lstStyle/>
+          <a:p>
+            <a:pPr algn="r" indent="0" marL="0">
+              <a:buNone/>
+            </a:pPr>
+            <a:r>
+              <a:rPr lang="en-US" sz="1100" b="1" dirty="0">
+                <a:solidFill>
+                  <a:srgbClr val="16324B"/>
+                </a:solidFill>
+                <a:latin typeface="Arial" pitchFamily="34" charset="0"/>
+                <a:ea typeface="Arial" pitchFamily="34" charset="-122"/>
+                <a:cs typeface="Arial" pitchFamily="34" charset="-120"/>
+              </a:rPr>
+              <a:t>19</a:t>
+            </a:r>
+            <a:endParaRPr lang="en-US" sz="1100" dirty="0"/>
+          </a:p>
+        </p:txBody>
+      </p:sp>
+      <p:sp>
+        <p:nvSpPr>
+          <p:cNvPr id="53" name="Shape 51"/>
+          <p:cNvSpPr/>
+          <p:nvPr/>
+        </p:nvSpPr>
+        <p:spPr>
+          <a:xfrm>
+            <a:off x="731520" y="5404104"/>
+            <a:ext cx="109728" cy="64008"/>
+          </a:xfrm>
+          <a:prstGeom prst="rect">
+            <a:avLst/>
+          </a:prstGeom>
+          <a:solidFill>
+            <a:srgbClr val="6E7F32"/>
+          </a:solidFill>
+          <a:ln/>
+        </p:spPr>
+      </p:sp>
+      <p:sp>
+        <p:nvSpPr>
+          <p:cNvPr id="54" name="Shape 52"/>
           <p:cNvSpPr/>
           <p:nvPr/>
         </p:nvSpPr>
@@ -14234,7 +14388,7 @@
       </p:sp>
       <p:sp>
         <p:nvSpPr>
-          <p:cNvPr id="50" name="Shape 48"/>
+          <p:cNvPr id="55" name="Shape 53"/>
           <p:cNvSpPr/>
           <p:nvPr/>
         </p:nvSpPr>
@@ -14254,7 +14408,7 @@
       </p:sp>
       <p:sp>
         <p:nvSpPr>
-          <p:cNvPr id="51" name="Text 49"/>
+          <p:cNvPr id="56" name="Text 54"/>
           <p:cNvSpPr/>
           <p:nvPr/>
         </p:nvSpPr>
@@ -14293,7 +14447,7 @@
       </p:sp>
       <p:sp>
         <p:nvSpPr>
-          <p:cNvPr id="52" name="Text 50"/>
+          <p:cNvPr id="57" name="Text 55"/>
           <p:cNvSpPr/>
           <p:nvPr/>
         </p:nvSpPr>
@@ -14332,7 +14486,7 @@
       </p:sp>
       <p:sp>
         <p:nvSpPr>
-          <p:cNvPr id="53" name="Text 51"/>
+          <p:cNvPr id="58" name="Text 56"/>
           <p:cNvSpPr/>
           <p:nvPr/>
         </p:nvSpPr>
@@ -14371,7 +14525,7 @@
       </p:sp>
       <p:sp>
         <p:nvSpPr>
-          <p:cNvPr id="54" name="Shape 52"/>
+          <p:cNvPr id="59" name="Shape 57"/>
           <p:cNvSpPr/>
           <p:nvPr/>
         </p:nvSpPr>
@@ -14391,7 +14545,7 @@
       </p:sp>
       <p:sp>
         <p:nvSpPr>
-          <p:cNvPr id="55" name="Text 53"/>
+          <p:cNvPr id="60" name="Text 58"/>
           <p:cNvSpPr/>
           <p:nvPr/>
         </p:nvSpPr>
@@ -14430,7 +14584,7 @@
       </p:sp>
       <p:sp>
         <p:nvSpPr>
-          <p:cNvPr id="56" name="Text 54"/>
+          <p:cNvPr id="61" name="Text 59"/>
           <p:cNvSpPr/>
           <p:nvPr/>
         </p:nvSpPr>
@@ -14469,7 +14623,7 @@
       </p:sp>
       <p:sp>
         <p:nvSpPr>
-          <p:cNvPr id="57" name="Shape 55"/>
+          <p:cNvPr id="62" name="Shape 60"/>
           <p:cNvSpPr/>
           <p:nvPr/>
         </p:nvSpPr>
@@ -14489,7 +14643,7 @@
       </p:sp>
       <p:sp>
         <p:nvSpPr>
-          <p:cNvPr id="58" name="Text 56"/>
+          <p:cNvPr id="63" name="Text 61"/>
           <p:cNvSpPr/>
           <p:nvPr/>
         </p:nvSpPr>
@@ -14528,7 +14682,7 @@
       </p:sp>
       <p:sp>
         <p:nvSpPr>
-          <p:cNvPr id="59" name="Text 57"/>
+          <p:cNvPr id="64" name="Text 62"/>
           <p:cNvSpPr/>
           <p:nvPr/>
         </p:nvSpPr>
@@ -14567,7 +14721,7 @@
       </p:sp>
       <p:sp>
         <p:nvSpPr>
-          <p:cNvPr id="60" name="Shape 58"/>
+          <p:cNvPr id="65" name="Shape 63"/>
           <p:cNvSpPr/>
           <p:nvPr/>
         </p:nvSpPr>
@@ -14587,7 +14741,7 @@
       </p:sp>
       <p:sp>
         <p:nvSpPr>
-          <p:cNvPr id="61" name="Shape 59"/>
+          <p:cNvPr id="66" name="Shape 64"/>
           <p:cNvSpPr/>
           <p:nvPr/>
         </p:nvSpPr>
@@ -14612,7 +14766,7 @@
       </p:sp>
       <p:sp>
         <p:nvSpPr>
-          <p:cNvPr id="62" name="Shape 60"/>
+          <p:cNvPr id="67" name="Shape 65"/>
           <p:cNvSpPr/>
           <p:nvPr/>
         </p:nvSpPr>
@@ -14632,7 +14786,7 @@
       </p:sp>
       <p:sp>
         <p:nvSpPr>
-          <p:cNvPr id="63" name="Text 61"/>
+          <p:cNvPr id="68" name="Text 66"/>
           <p:cNvSpPr/>
           <p:nvPr/>
         </p:nvSpPr>
@@ -14671,7 +14825,7 @@
       </p:sp>
       <p:sp>
         <p:nvSpPr>
-          <p:cNvPr id="64" name="Text 62"/>
+          <p:cNvPr id="69" name="Text 67"/>
           <p:cNvSpPr/>
           <p:nvPr/>
         </p:nvSpPr>
@@ -14710,7 +14864,7 @@
       </p:sp>
       <p:sp>
         <p:nvSpPr>
-          <p:cNvPr id="65" name="Text 63"/>
+          <p:cNvPr id="70" name="Text 68"/>
           <p:cNvSpPr/>
           <p:nvPr/>
         </p:nvSpPr>
@@ -14749,7 +14903,7 @@
       </p:sp>
       <p:sp>
         <p:nvSpPr>
-          <p:cNvPr id="66" name="Shape 64"/>
+          <p:cNvPr id="71" name="Shape 69"/>
           <p:cNvSpPr/>
           <p:nvPr/>
         </p:nvSpPr>
@@ -14769,7 +14923,7 @@
       </p:sp>
       <p:sp>
         <p:nvSpPr>
-          <p:cNvPr id="67" name="Text 65"/>
+          <p:cNvPr id="72" name="Text 70"/>
           <p:cNvSpPr/>
           <p:nvPr/>
         </p:nvSpPr>
@@ -14808,7 +14962,7 @@
       </p:sp>
       <p:sp>
         <p:nvSpPr>
-          <p:cNvPr id="68" name="Text 66"/>
+          <p:cNvPr id="73" name="Text 71"/>
           <p:cNvSpPr/>
           <p:nvPr/>
         </p:nvSpPr>
@@ -14847,7 +15001,7 @@
       </p:sp>
       <p:sp>
         <p:nvSpPr>
-          <p:cNvPr id="69" name="Shape 67"/>
+          <p:cNvPr id="74" name="Shape 72"/>
           <p:cNvSpPr/>
           <p:nvPr/>
         </p:nvSpPr>
@@ -14867,7 +15021,7 @@
       </p:sp>
       <p:sp>
         <p:nvSpPr>
-          <p:cNvPr id="70" name="Text 68"/>
+          <p:cNvPr id="75" name="Text 73"/>
           <p:cNvSpPr/>
           <p:nvPr/>
         </p:nvSpPr>
@@ -14906,7 +15060,7 @@
       </p:sp>
       <p:sp>
         <p:nvSpPr>
-          <p:cNvPr id="71" name="Text 69"/>
+          <p:cNvPr id="76" name="Text 74"/>
           <p:cNvSpPr/>
           <p:nvPr/>
         </p:nvSpPr>
@@ -14945,7 +15099,7 @@
       </p:sp>
       <p:sp>
         <p:nvSpPr>
-          <p:cNvPr id="72" name="Shape 70"/>
+          <p:cNvPr id="77" name="Shape 75"/>
           <p:cNvSpPr/>
           <p:nvPr/>
         </p:nvSpPr>
@@ -14965,7 +15119,7 @@
       </p:sp>
       <p:sp>
         <p:nvSpPr>
-          <p:cNvPr id="73" name="Text 71"/>
+          <p:cNvPr id="78" name="Text 76"/>
           <p:cNvSpPr/>
           <p:nvPr/>
         </p:nvSpPr>
@@ -15007,7 +15161,7 @@
       </p:sp>
       <p:sp>
         <p:nvSpPr>
-          <p:cNvPr id="74" name="Shape 72"/>
+          <p:cNvPr id="79" name="Shape 77"/>
           <p:cNvSpPr/>
           <p:nvPr/>
         </p:nvSpPr>
@@ -15027,7 +15181,7 @@
       </p:sp>
       <p:sp>
         <p:nvSpPr>
-          <p:cNvPr id="75" name="Text 73"/>
+          <p:cNvPr id="80" name="Text 78"/>
           <p:cNvSpPr/>
           <p:nvPr/>
         </p:nvSpPr>
@@ -15066,7 +15220,7 @@
       </p:sp>
       <p:sp>
         <p:nvSpPr>
-          <p:cNvPr id="76" name="Text 74"/>
+          <p:cNvPr id="81" name="Text 79"/>
           <p:cNvSpPr/>
           <p:nvPr/>
         </p:nvSpPr>
@@ -15105,7 +15259,7 @@
       </p:sp>
       <p:sp>
         <p:nvSpPr>
-          <p:cNvPr id="77" name="Shape 75"/>
+          <p:cNvPr id="82" name="Shape 80"/>
           <p:cNvSpPr/>
           <p:nvPr/>
         </p:nvSpPr>
@@ -15125,7 +15279,7 @@
       </p:sp>
       <p:sp>
         <p:nvSpPr>
-          <p:cNvPr id="78" name="Text 76"/>
+          <p:cNvPr id="83" name="Text 81"/>
           <p:cNvSpPr/>
           <p:nvPr/>
         </p:nvSpPr>

</xml_diff>